<commit_message>
Fix PPTX that PowerPoint refused to open (zero-extent line shapes)
PowerPoint rejected the deck ("can't read") because pptxgenjs emits
perfectly horizontal/vertical LINE shapes with a zero-dimension bounding
box (cx=0 / cy=0) for rules, dividers, brackets, and roadmap connectors.
XSD/LibreOffice validators and python-pptx tolerate this; PowerPoint does not.

- Give every line shape a tiny non-zero perpendicular extent (renders identically).
- Normalize the package through python-pptx, which writes OOXML PowerPoint reads reliably.
- Re-validated, zip-integrity checked, reopened, and re-rendered all 18 slides.

Co-Authored-By: Claude Opus 4.8 <noreply@anthropic.com>
Claude-Session: https://claude.ai/code/session_019DGdwdNtwgGtbVgZozCYCr
</commit_message>
<xml_diff>
--- a/Design_Amplified.pptx
+++ b/Design_Amplified.pptx
@@ -2397,7 +2397,7 @@
         <p:spPr>
           <a:xfrm>
             <a:off x="457200" y="384048"/>
-            <a:ext cx="310896" cy="0"/>
+            <a:ext cx="310896" cy="7315"/>
           </a:xfrm>
           <a:prstGeom prst="line">
             <a:avLst/>
@@ -2420,7 +2420,7 @@
         <p:spPr>
           <a:xfrm>
             <a:off x="457200" y="384048"/>
-            <a:ext cx="0" cy="310896"/>
+            <a:ext cx="7315" cy="310896"/>
           </a:xfrm>
           <a:prstGeom prst="line">
             <a:avLst/>
@@ -2443,7 +2443,7 @@
         <p:spPr>
           <a:xfrm>
             <a:off x="11731752" y="384048"/>
-            <a:ext cx="-310896" cy="0"/>
+            <a:ext cx="-310896" cy="7315"/>
           </a:xfrm>
           <a:prstGeom prst="line">
             <a:avLst/>
@@ -2466,7 +2466,7 @@
         <p:spPr>
           <a:xfrm>
             <a:off x="11731752" y="384048"/>
-            <a:ext cx="0" cy="310896"/>
+            <a:ext cx="7315" cy="310896"/>
           </a:xfrm>
           <a:prstGeom prst="line">
             <a:avLst/>
@@ -2489,7 +2489,7 @@
         <p:spPr>
           <a:xfrm>
             <a:off x="457200" y="6473952"/>
-            <a:ext cx="310896" cy="0"/>
+            <a:ext cx="310896" cy="7315"/>
           </a:xfrm>
           <a:prstGeom prst="line">
             <a:avLst/>
@@ -2512,7 +2512,7 @@
         <p:spPr>
           <a:xfrm>
             <a:off x="457200" y="6473952"/>
-            <a:ext cx="0" cy="-310896"/>
+            <a:ext cx="7315" cy="-310896"/>
           </a:xfrm>
           <a:prstGeom prst="line">
             <a:avLst/>
@@ -2535,7 +2535,7 @@
         <p:spPr>
           <a:xfrm>
             <a:off x="11731752" y="6473952"/>
-            <a:ext cx="-310896" cy="0"/>
+            <a:ext cx="-310896" cy="7315"/>
           </a:xfrm>
           <a:prstGeom prst="line">
             <a:avLst/>
@@ -2558,7 +2558,7 @@
         <p:spPr>
           <a:xfrm>
             <a:off x="11731752" y="6473952"/>
-            <a:ext cx="0" cy="-310896"/>
+            <a:ext cx="7315" cy="-310896"/>
           </a:xfrm>
           <a:prstGeom prst="line">
             <a:avLst/>
@@ -4553,7 +4553,7 @@
         <p:spPr>
           <a:xfrm>
             <a:off x="10625328" y="1005840"/>
-            <a:ext cx="256032" cy="0"/>
+            <a:ext cx="256032" cy="7315"/>
           </a:xfrm>
           <a:prstGeom prst="line">
             <a:avLst/>
@@ -4779,7 +4779,7 @@
         <p:spPr>
           <a:xfrm>
             <a:off x="4183380" y="1600200"/>
-            <a:ext cx="0" cy="3977640"/>
+            <a:ext cx="7315" cy="3977640"/>
           </a:xfrm>
           <a:prstGeom prst="line">
             <a:avLst/>
@@ -4939,7 +4939,7 @@
         <p:spPr>
           <a:xfrm>
             <a:off x="6675120" y="1600200"/>
-            <a:ext cx="0" cy="3977640"/>
+            <a:ext cx="7315" cy="3977640"/>
           </a:xfrm>
           <a:prstGeom prst="line">
             <a:avLst/>
@@ -5099,7 +5099,7 @@
         <p:spPr>
           <a:xfrm>
             <a:off x="9166860" y="1600200"/>
-            <a:ext cx="0" cy="3977640"/>
+            <a:ext cx="7315" cy="3977640"/>
           </a:xfrm>
           <a:prstGeom prst="line">
             <a:avLst/>
@@ -5505,7 +5505,7 @@
         <p:spPr>
           <a:xfrm>
             <a:off x="2148840" y="2945892"/>
-            <a:ext cx="9372600" cy="0"/>
+            <a:ext cx="9372600" cy="7315"/>
           </a:xfrm>
           <a:prstGeom prst="line">
             <a:avLst/>
@@ -5721,7 +5721,7 @@
         <p:spPr>
           <a:xfrm>
             <a:off x="3074670" y="3936492"/>
-            <a:ext cx="8446770" cy="0"/>
+            <a:ext cx="8446770" cy="7315"/>
           </a:xfrm>
           <a:prstGeom prst="line">
             <a:avLst/>
@@ -6003,7 +6003,7 @@
         <p:spPr>
           <a:xfrm>
             <a:off x="5566410" y="4927092"/>
-            <a:ext cx="3554730" cy="0"/>
+            <a:ext cx="3554730" cy="7315"/>
           </a:xfrm>
           <a:prstGeom prst="line">
             <a:avLst/>
@@ -7071,7 +7071,7 @@
         <p:spPr>
           <a:xfrm>
             <a:off x="749808" y="4919472"/>
-            <a:ext cx="2304288" cy="0"/>
+            <a:ext cx="2304288" cy="7315"/>
           </a:xfrm>
           <a:prstGeom prst="line">
             <a:avLst/>
@@ -7876,7 +7876,7 @@
         <p:spPr>
           <a:xfrm>
             <a:off x="3602736" y="4919472"/>
-            <a:ext cx="2304288" cy="0"/>
+            <a:ext cx="2304288" cy="7315"/>
           </a:xfrm>
           <a:prstGeom prst="line">
             <a:avLst/>
@@ -8740,7 +8740,7 @@
         <p:spPr>
           <a:xfrm>
             <a:off x="6455664" y="4919472"/>
-            <a:ext cx="2304288" cy="0"/>
+            <a:ext cx="2304288" cy="7315"/>
           </a:xfrm>
           <a:prstGeom prst="line">
             <a:avLst/>
@@ -9427,7 +9427,7 @@
         <p:spPr>
           <a:xfrm>
             <a:off x="9308592" y="4919472"/>
-            <a:ext cx="2304288" cy="0"/>
+            <a:ext cx="2304288" cy="7315"/>
           </a:xfrm>
           <a:prstGeom prst="line">
             <a:avLst/>
@@ -12019,7 +12019,7 @@
         <p:spPr>
           <a:xfrm>
             <a:off x="3520440" y="3044952"/>
-            <a:ext cx="8046720" cy="0"/>
+            <a:ext cx="8046720" cy="7315"/>
           </a:xfrm>
           <a:prstGeom prst="line">
             <a:avLst/>
@@ -12228,7 +12228,7 @@
         <p:spPr>
           <a:xfrm>
             <a:off x="3520440" y="3977640"/>
-            <a:ext cx="8046720" cy="0"/>
+            <a:ext cx="8046720" cy="7315"/>
           </a:xfrm>
           <a:prstGeom prst="line">
             <a:avLst/>
@@ -12437,7 +12437,7 @@
         <p:spPr>
           <a:xfrm>
             <a:off x="3520440" y="4910328"/>
-            <a:ext cx="8046720" cy="0"/>
+            <a:ext cx="8046720" cy="7315"/>
           </a:xfrm>
           <a:prstGeom prst="line">
             <a:avLst/>
@@ -14974,7 +14974,7 @@
         <p:spPr>
           <a:xfrm>
             <a:off x="457200" y="384048"/>
-            <a:ext cx="310896" cy="0"/>
+            <a:ext cx="310896" cy="7315"/>
           </a:xfrm>
           <a:prstGeom prst="line">
             <a:avLst/>
@@ -14997,7 +14997,7 @@
         <p:spPr>
           <a:xfrm>
             <a:off x="457200" y="384048"/>
-            <a:ext cx="0" cy="310896"/>
+            <a:ext cx="7315" cy="310896"/>
           </a:xfrm>
           <a:prstGeom prst="line">
             <a:avLst/>
@@ -15020,7 +15020,7 @@
         <p:spPr>
           <a:xfrm>
             <a:off x="11731752" y="384048"/>
-            <a:ext cx="-310896" cy="0"/>
+            <a:ext cx="-310896" cy="7315"/>
           </a:xfrm>
           <a:prstGeom prst="line">
             <a:avLst/>
@@ -15043,7 +15043,7 @@
         <p:spPr>
           <a:xfrm>
             <a:off x="11731752" y="384048"/>
-            <a:ext cx="0" cy="310896"/>
+            <a:ext cx="7315" cy="310896"/>
           </a:xfrm>
           <a:prstGeom prst="line">
             <a:avLst/>
@@ -15066,7 +15066,7 @@
         <p:spPr>
           <a:xfrm>
             <a:off x="457200" y="6473952"/>
-            <a:ext cx="310896" cy="0"/>
+            <a:ext cx="310896" cy="7315"/>
           </a:xfrm>
           <a:prstGeom prst="line">
             <a:avLst/>
@@ -15089,7 +15089,7 @@
         <p:spPr>
           <a:xfrm>
             <a:off x="457200" y="6473952"/>
-            <a:ext cx="0" cy="-310896"/>
+            <a:ext cx="7315" cy="-310896"/>
           </a:xfrm>
           <a:prstGeom prst="line">
             <a:avLst/>
@@ -15112,7 +15112,7 @@
         <p:spPr>
           <a:xfrm>
             <a:off x="11731752" y="6473952"/>
-            <a:ext cx="-310896" cy="0"/>
+            <a:ext cx="-310896" cy="7315"/>
           </a:xfrm>
           <a:prstGeom prst="line">
             <a:avLst/>
@@ -15135,7 +15135,7 @@
         <p:spPr>
           <a:xfrm>
             <a:off x="11731752" y="6473952"/>
-            <a:ext cx="0" cy="-310896"/>
+            <a:ext cx="7315" cy="-310896"/>
           </a:xfrm>
           <a:prstGeom prst="line">
             <a:avLst/>
@@ -16488,7 +16488,7 @@
         <p:spPr>
           <a:xfrm>
             <a:off x="548640" y="2606040"/>
-            <a:ext cx="11091672" cy="0"/>
+            <a:ext cx="11091672" cy="7315"/>
           </a:xfrm>
           <a:prstGeom prst="line">
             <a:avLst/>
@@ -16550,7 +16550,7 @@
         <p:spPr>
           <a:xfrm>
             <a:off x="2331720" y="3108960"/>
-            <a:ext cx="9326880" cy="0"/>
+            <a:ext cx="9326880" cy="7315"/>
           </a:xfrm>
           <a:prstGeom prst="line">
             <a:avLst/>
@@ -16837,7 +16837,7 @@
         <p:spPr>
           <a:xfrm>
             <a:off x="548640" y="3657600"/>
-            <a:ext cx="11091672" cy="0"/>
+            <a:ext cx="11091672" cy="7315"/>
           </a:xfrm>
           <a:prstGeom prst="line">
             <a:avLst/>
@@ -16899,7 +16899,7 @@
         <p:spPr>
           <a:xfrm>
             <a:off x="2331720" y="4160520"/>
-            <a:ext cx="9326880" cy="0"/>
+            <a:ext cx="9326880" cy="7315"/>
           </a:xfrm>
           <a:prstGeom prst="line">
             <a:avLst/>
@@ -17186,7 +17186,7 @@
         <p:spPr>
           <a:xfrm>
             <a:off x="548640" y="4709160"/>
-            <a:ext cx="11091672" cy="0"/>
+            <a:ext cx="11091672" cy="7315"/>
           </a:xfrm>
           <a:prstGeom prst="line">
             <a:avLst/>
@@ -17248,7 +17248,7 @@
         <p:spPr>
           <a:xfrm>
             <a:off x="2331720" y="5212080"/>
-            <a:ext cx="9326880" cy="0"/>
+            <a:ext cx="9326880" cy="7315"/>
           </a:xfrm>
           <a:prstGeom prst="line">
             <a:avLst/>
@@ -22125,7 +22125,7 @@
         <p:spPr>
           <a:xfrm>
             <a:off x="457200" y="384048"/>
-            <a:ext cx="310896" cy="0"/>
+            <a:ext cx="310896" cy="7315"/>
           </a:xfrm>
           <a:prstGeom prst="line">
             <a:avLst/>
@@ -22148,7 +22148,7 @@
         <p:spPr>
           <a:xfrm>
             <a:off x="457200" y="384048"/>
-            <a:ext cx="0" cy="310896"/>
+            <a:ext cx="7315" cy="310896"/>
           </a:xfrm>
           <a:prstGeom prst="line">
             <a:avLst/>
@@ -22171,7 +22171,7 @@
         <p:spPr>
           <a:xfrm>
             <a:off x="11731752" y="384048"/>
-            <a:ext cx="-310896" cy="0"/>
+            <a:ext cx="-310896" cy="7315"/>
           </a:xfrm>
           <a:prstGeom prst="line">
             <a:avLst/>
@@ -22194,7 +22194,7 @@
         <p:spPr>
           <a:xfrm>
             <a:off x="11731752" y="384048"/>
-            <a:ext cx="0" cy="310896"/>
+            <a:ext cx="7315" cy="310896"/>
           </a:xfrm>
           <a:prstGeom prst="line">
             <a:avLst/>
@@ -22217,7 +22217,7 @@
         <p:spPr>
           <a:xfrm>
             <a:off x="457200" y="6473952"/>
-            <a:ext cx="310896" cy="0"/>
+            <a:ext cx="310896" cy="7315"/>
           </a:xfrm>
           <a:prstGeom prst="line">
             <a:avLst/>
@@ -22240,7 +22240,7 @@
         <p:spPr>
           <a:xfrm>
             <a:off x="457200" y="6473952"/>
-            <a:ext cx="0" cy="-310896"/>
+            <a:ext cx="7315" cy="-310896"/>
           </a:xfrm>
           <a:prstGeom prst="line">
             <a:avLst/>
@@ -22263,7 +22263,7 @@
         <p:spPr>
           <a:xfrm>
             <a:off x="11731752" y="6473952"/>
-            <a:ext cx="-310896" cy="0"/>
+            <a:ext cx="-310896" cy="7315"/>
           </a:xfrm>
           <a:prstGeom prst="line">
             <a:avLst/>
@@ -22286,7 +22286,7 @@
         <p:spPr>
           <a:xfrm>
             <a:off x="11731752" y="6473952"/>
-            <a:ext cx="0" cy="-310896"/>
+            <a:ext cx="7315" cy="-310896"/>
           </a:xfrm>
           <a:prstGeom prst="line">
             <a:avLst/>
@@ -23277,7 +23277,7 @@
         <p:spPr>
           <a:xfrm>
             <a:off x="804672" y="4846320"/>
-            <a:ext cx="3099816" cy="0"/>
+            <a:ext cx="3099816" cy="7315"/>
           </a:xfrm>
           <a:prstGeom prst="line">
             <a:avLst/>
@@ -23672,7 +23672,7 @@
         <p:spPr>
           <a:xfrm>
             <a:off x="4553712" y="4846320"/>
-            <a:ext cx="3099816" cy="0"/>
+            <a:ext cx="3099816" cy="7315"/>
           </a:xfrm>
           <a:prstGeom prst="line">
             <a:avLst/>
@@ -24129,7 +24129,7 @@
         <p:spPr>
           <a:xfrm>
             <a:off x="8302752" y="4846320"/>
-            <a:ext cx="3099816" cy="0"/>
+            <a:ext cx="3099816" cy="7315"/>
           </a:xfrm>
           <a:prstGeom prst="line">
             <a:avLst/>

</xml_diff>